<commit_message>
fix(presentacion): corrige 4 errores en el pptx
- Slide 5:  443 Tests -> 720 Tests automatizados
- Slide 11: '7pp mejor' -> '7.1 pp mejor' (cifra exacta del articulo)
- Slide 12: 'Tres herramientas' -> 'Seis herramientas'; las 3 tarjetas
  muestran ahora los 6 tools del agente (pares): predecir+comparar,
  consultar_trafico+obtener_clima, verificar_perturbaciones+obtener_lugares
- Slide 16: github.com/Palermo01 -> github.com/caledelta

Co-Authored-By: Claude Sonnet 4.6 <noreply@anthropic.com>
</commit_message>
<xml_diff>
--- a/docs/UrbanFlow_CDMX_Presentacion.pptx
+++ b/docs/UrbanFlow_CDMX_Presentacion.pptx
@@ -2234,6 +2234,10 @@
             <a:prstDash val="solid"/>
           </a:ln>
         </p:spPr>
+        <p:txBody>
+          <a:bodyPr/>
+          <a:p/>
+        </p:txBody>
       </p:sp>
       <p:sp>
         <p:nvSpPr>
@@ -2452,6 +2456,10 @@
             <a:prstDash val="solid"/>
           </a:ln>
         </p:spPr>
+        <p:txBody>
+          <a:bodyPr/>
+          <a:p/>
+        </p:txBody>
       </p:sp>
       <p:sp>
         <p:nvSpPr>
@@ -2587,6 +2595,10 @@
             <a:prstDash val="solid"/>
           </a:ln>
         </p:spPr>
+        <p:txBody>
+          <a:bodyPr/>
+          <a:p/>
+        </p:txBody>
       </p:sp>
       <p:sp>
         <p:nvSpPr>
@@ -2690,6 +2702,10 @@
             <a:prstDash val="solid"/>
           </a:ln>
         </p:spPr>
+        <p:txBody>
+          <a:bodyPr/>
+          <a:p/>
+        </p:txBody>
       </p:sp>
       <p:sp>
         <p:nvSpPr>
@@ -2754,6 +2770,10 @@
             <a:prstDash val="solid"/>
           </a:ln>
         </p:spPr>
+        <p:txBody>
+          <a:bodyPr/>
+          <a:p/>
+        </p:txBody>
       </p:sp>
       <p:sp>
         <p:nvSpPr>
@@ -3125,6 +3145,10 @@
             <a:prstDash val="solid"/>
           </a:ln>
         </p:spPr>
+        <p:txBody>
+          <a:bodyPr/>
+          <a:p/>
+        </p:txBody>
       </p:sp>
       <p:sp>
         <p:nvSpPr>
@@ -3157,6 +3181,10 @@
             </a:outerShdw>
           </a:effectLst>
         </p:spPr>
+        <p:txBody>
+          <a:bodyPr/>
+          <a:p/>
+        </p:txBody>
       </p:sp>
       <p:sp>
         <p:nvSpPr>
@@ -3223,6 +3251,10 @@
             <a:prstDash val="solid"/>
           </a:ln>
         </p:spPr>
+        <p:txBody>
+          <a:bodyPr/>
+          <a:p/>
+        </p:txBody>
       </p:sp>
       <p:sp>
         <p:nvSpPr>
@@ -3289,6 +3321,10 @@
             <a:prstDash val="solid"/>
           </a:ln>
         </p:spPr>
+        <p:txBody>
+          <a:bodyPr/>
+          <a:p/>
+        </p:txBody>
       </p:sp>
       <p:sp>
         <p:nvSpPr>
@@ -3355,6 +3391,10 @@
             <a:prstDash val="solid"/>
           </a:ln>
         </p:spPr>
+        <p:txBody>
+          <a:bodyPr/>
+          <a:p/>
+        </p:txBody>
       </p:sp>
       <p:sp>
         <p:nvSpPr>
@@ -3419,6 +3459,10 @@
             <a:prstDash val="solid"/>
           </a:ln>
         </p:spPr>
+        <p:txBody>
+          <a:bodyPr/>
+          <a:p/>
+        </p:txBody>
       </p:sp>
       <p:sp>
         <p:nvSpPr>
@@ -3554,6 +3598,10 @@
             <a:prstDash val="solid"/>
           </a:ln>
         </p:spPr>
+        <p:txBody>
+          <a:bodyPr/>
+          <a:p/>
+        </p:txBody>
       </p:sp>
       <p:sp>
         <p:nvSpPr>
@@ -3657,6 +3705,10 @@
             <a:prstDash val="solid"/>
           </a:ln>
         </p:spPr>
+        <p:txBody>
+          <a:bodyPr/>
+          <a:p/>
+        </p:txBody>
       </p:sp>
       <p:sp>
         <p:nvSpPr>
@@ -3728,6 +3780,10 @@
             </a:outerShdw>
           </a:effectLst>
         </p:spPr>
+        <p:txBody>
+          <a:bodyPr/>
+          <a:p/>
+        </p:txBody>
       </p:sp>
       <p:sp>
         <p:nvSpPr>
@@ -3753,6 +3809,10 @@
             <a:prstDash val="solid"/>
           </a:ln>
         </p:spPr>
+        <p:txBody>
+          <a:bodyPr/>
+          <a:p/>
+        </p:txBody>
       </p:sp>
       <p:pic>
         <p:nvPicPr>
@@ -3926,6 +3986,10 @@
             </a:outerShdw>
           </a:effectLst>
         </p:spPr>
+        <p:txBody>
+          <a:bodyPr/>
+          <a:p/>
+        </p:txBody>
       </p:sp>
       <p:sp>
         <p:nvSpPr>
@@ -3951,6 +4015,10 @@
             <a:prstDash val="solid"/>
           </a:ln>
         </p:spPr>
+        <p:txBody>
+          <a:bodyPr/>
+          <a:p/>
+        </p:txBody>
       </p:sp>
       <p:pic>
         <p:nvPicPr>
@@ -4124,6 +4192,10 @@
             </a:outerShdw>
           </a:effectLst>
         </p:spPr>
+        <p:txBody>
+          <a:bodyPr/>
+          <a:p/>
+        </p:txBody>
       </p:sp>
       <p:sp>
         <p:nvSpPr>
@@ -4149,6 +4221,10 @@
             <a:prstDash val="solid"/>
           </a:ln>
         </p:spPr>
+        <p:txBody>
+          <a:bodyPr/>
+          <a:p/>
+        </p:txBody>
       </p:sp>
       <p:pic>
         <p:nvPicPr>
@@ -4322,6 +4398,10 @@
             </a:outerShdw>
           </a:effectLst>
         </p:spPr>
+        <p:txBody>
+          <a:bodyPr/>
+          <a:p/>
+        </p:txBody>
       </p:sp>
       <p:sp>
         <p:nvSpPr>
@@ -4347,6 +4427,10 @@
             <a:prstDash val="solid"/>
           </a:ln>
         </p:spPr>
+        <p:txBody>
+          <a:bodyPr/>
+          <a:p/>
+        </p:txBody>
       </p:sp>
       <p:pic>
         <p:nvPicPr>
@@ -4483,7 +4567,7 @@
                 <a:ea typeface="Calibri" pitchFamily="34" charset="-122"/>
                 <a:cs typeface="Calibri" pitchFamily="34" charset="-120"/>
               </a:rPr>
-              <a:t>VialAI es 7pp mejor</a:t>
+              <a:t>VialAI es 7.1 pp mejor</a:t>
             </a:r>
             <a:endParaRPr lang="en-US" sz="1200" dirty="0"/>
           </a:p>
@@ -4584,6 +4668,10 @@
             <a:prstDash val="solid"/>
           </a:ln>
         </p:spPr>
+        <p:txBody>
+          <a:bodyPr/>
+          <a:p/>
+        </p:txBody>
       </p:sp>
       <p:sp>
         <p:nvSpPr>
@@ -4687,6 +4775,10 @@
             <a:prstDash val="solid"/>
           </a:ln>
         </p:spPr>
+        <p:txBody>
+          <a:bodyPr/>
+          <a:p/>
+        </p:txBody>
       </p:sp>
       <p:sp>
         <p:nvSpPr>
@@ -4758,6 +4850,10 @@
             </a:outerShdw>
           </a:effectLst>
         </p:spPr>
+        <p:txBody>
+          <a:bodyPr/>
+          <a:p/>
+        </p:txBody>
       </p:sp>
       <p:pic>
         <p:nvPicPr>
@@ -4885,6 +4981,10 @@
             <a:prstDash val="solid"/>
           </a:ln>
         </p:spPr>
+        <p:txBody>
+          <a:bodyPr/>
+          <a:p/>
+        </p:txBody>
       </p:sp>
       <p:sp>
         <p:nvSpPr>
@@ -4917,6 +5017,10 @@
             </a:outerShdw>
           </a:effectLst>
         </p:spPr>
+        <p:txBody>
+          <a:bodyPr/>
+          <a:p/>
+        </p:txBody>
       </p:sp>
       <p:pic>
         <p:nvPicPr>
@@ -5044,6 +5148,10 @@
             <a:prstDash val="solid"/>
           </a:ln>
         </p:spPr>
+        <p:txBody>
+          <a:bodyPr/>
+          <a:p/>
+        </p:txBody>
       </p:sp>
       <p:sp>
         <p:nvSpPr>
@@ -5076,6 +5184,10 @@
             </a:outerShdw>
           </a:effectLst>
         </p:spPr>
+        <p:txBody>
+          <a:bodyPr/>
+          <a:p/>
+        </p:txBody>
       </p:sp>
       <p:pic>
         <p:nvPicPr>
@@ -5203,6 +5315,10 @@
             <a:prstDash val="solid"/>
           </a:ln>
         </p:spPr>
+        <p:txBody>
+          <a:bodyPr/>
+          <a:p/>
+        </p:txBody>
       </p:sp>
       <p:sp>
         <p:nvSpPr>
@@ -5235,6 +5351,10 @@
             </a:outerShdw>
           </a:effectLst>
         </p:spPr>
+        <p:txBody>
+          <a:bodyPr/>
+          <a:p/>
+        </p:txBody>
       </p:sp>
       <p:pic>
         <p:nvPicPr>
@@ -5362,6 +5482,10 @@
             <a:prstDash val="solid"/>
           </a:ln>
         </p:spPr>
+        <p:txBody>
+          <a:bodyPr/>
+          <a:p/>
+        </p:txBody>
       </p:sp>
       <p:sp>
         <p:nvSpPr>
@@ -5394,6 +5518,10 @@
             </a:outerShdw>
           </a:effectLst>
         </p:spPr>
+        <p:txBody>
+          <a:bodyPr/>
+          <a:p/>
+        </p:txBody>
       </p:sp>
       <p:pic>
         <p:nvPicPr>
@@ -5530,7 +5658,7 @@
                 <a:ea typeface="Calibri" pitchFamily="34" charset="-122"/>
                 <a:cs typeface="Calibri" pitchFamily="34" charset="-120"/>
               </a:rPr>
-              <a:t>Tres herramientas expuestas al agente vía function calling</a:t>
+              <a:t>Seis herramientas expuestas al agente vía function calling</a:t>
             </a:r>
             <a:endParaRPr lang="en-US" sz="1600" dirty="0"/>
           </a:p>
@@ -5567,6 +5695,10 @@
             </a:outerShdw>
           </a:effectLst>
         </p:spPr>
+        <p:txBody>
+          <a:bodyPr/>
+          <a:p/>
+        </p:txBody>
       </p:sp>
       <p:sp>
         <p:nvSpPr>
@@ -5592,6 +5724,10 @@
             <a:prstDash val="solid"/>
           </a:ln>
         </p:spPr>
+        <p:txBody>
+          <a:bodyPr/>
+          <a:p/>
+        </p:txBody>
       </p:sp>
       <p:sp>
         <p:nvSpPr>
@@ -5618,7 +5754,7 @@
               <a:buNone/>
             </a:pPr>
             <a:r>
-              <a:rPr lang="en-US" sz="1300" b="1" dirty="0">
+              <a:rPr lang="en-US" sz="900" b="1" dirty="0">
                 <a:solidFill>
                   <a:srgbClr val="0C4A6E"/>
                 </a:solidFill>
@@ -5626,7 +5762,7 @@
                 <a:ea typeface="Consolas" pitchFamily="34" charset="-122"/>
                 <a:cs typeface="Consolas" pitchFamily="34" charset="-120"/>
               </a:rPr>
-              <a:t>predecir_tiempo_viaje()</a:t>
+              <a:t>predecir_tiempo_viaje()  ·  comparar_rutas()</a:t>
             </a:r>
             <a:endParaRPr lang="en-US" sz="1300" dirty="0"/>
           </a:p>
@@ -5657,7 +5793,7 @@
               <a:buNone/>
             </a:pPr>
             <a:r>
-              <a:rPr lang="en-US" sz="1100" dirty="0">
+              <a:rPr lang="en-US" sz="900" dirty="0">
                 <a:solidFill>
                   <a:srgbClr val="475569"/>
                 </a:solidFill>
@@ -5665,7 +5801,8 @@
                 <a:ea typeface="Calibri" pitchFamily="34" charset="-122"/>
                 <a:cs typeface="Calibri" pitchFamily="34" charset="-120"/>
               </a:rPr>
-              <a:t>Origen, destino, hora → P10/P50/P90 + IC</a:t>
+              <a:t>Origen, destino, hora → P10/P50/P90 + IC
+Compara múltiples rutas en paralelo</a:t>
             </a:r>
             <a:endParaRPr lang="en-US" sz="1100" dirty="0"/>
           </a:p>
@@ -5702,6 +5839,10 @@
             </a:outerShdw>
           </a:effectLst>
         </p:spPr>
+        <p:txBody>
+          <a:bodyPr/>
+          <a:p/>
+        </p:txBody>
       </p:sp>
       <p:sp>
         <p:nvSpPr>
@@ -5727,6 +5868,10 @@
             <a:prstDash val="solid"/>
           </a:ln>
         </p:spPr>
+        <p:txBody>
+          <a:bodyPr/>
+          <a:p/>
+        </p:txBody>
       </p:sp>
       <p:sp>
         <p:nvSpPr>
@@ -5753,7 +5898,7 @@
               <a:buNone/>
             </a:pPr>
             <a:r>
-              <a:rPr lang="en-US" sz="1300" b="1" dirty="0">
+              <a:rPr lang="en-US" sz="900" b="1" dirty="0">
                 <a:solidFill>
                   <a:srgbClr val="D97706"/>
                 </a:solidFill>
@@ -5761,7 +5906,7 @@
                 <a:ea typeface="Consolas" pitchFamily="34" charset="-122"/>
                 <a:cs typeface="Consolas" pitchFamily="34" charset="-120"/>
               </a:rPr>
-              <a:t>consultar_trafico_ahora()</a:t>
+              <a:t>consultar_trafico_ahora()  ·  obtener_clima()</a:t>
             </a:r>
             <a:endParaRPr lang="en-US" sz="1300" dirty="0"/>
           </a:p>
@@ -5792,7 +5937,7 @@
               <a:buNone/>
             </a:pPr>
             <a:r>
-              <a:rPr lang="en-US" sz="1100" dirty="0">
+              <a:rPr lang="en-US" sz="900" dirty="0">
                 <a:solidFill>
                   <a:srgbClr val="475569"/>
                 </a:solidFill>
@@ -5800,7 +5945,8 @@
                 <a:ea typeface="Calibri" pitchFamily="34" charset="-122"/>
                 <a:cs typeface="Calibri" pitchFamily="34" charset="-120"/>
               </a:rPr>
-              <a:t>Zona → estado actual + ratio de congestión</a:t>
+              <a:t>Zona → estado actual + ratio de congestión
+Clima vigente + factor de ajuste de velocidad</a:t>
             </a:r>
             <a:endParaRPr lang="en-US" sz="1100" dirty="0"/>
           </a:p>
@@ -5837,6 +5983,10 @@
             </a:outerShdw>
           </a:effectLst>
         </p:spPr>
+        <p:txBody>
+          <a:bodyPr/>
+          <a:p/>
+        </p:txBody>
       </p:sp>
       <p:sp>
         <p:nvSpPr>
@@ -5862,6 +6012,10 @@
             <a:prstDash val="solid"/>
           </a:ln>
         </p:spPr>
+        <p:txBody>
+          <a:bodyPr/>
+          <a:p/>
+        </p:txBody>
       </p:sp>
       <p:sp>
         <p:nvSpPr>
@@ -5888,7 +6042,7 @@
               <a:buNone/>
             </a:pPr>
             <a:r>
-              <a:rPr lang="en-US" sz="1300" b="1" dirty="0">
+              <a:rPr lang="en-US" sz="900" b="1" dirty="0">
                 <a:solidFill>
                   <a:srgbClr val="15803D"/>
                 </a:solidFill>
@@ -5896,7 +6050,7 @@
                 <a:ea typeface="Consolas" pitchFamily="34" charset="-122"/>
                 <a:cs typeface="Consolas" pitchFamily="34" charset="-120"/>
               </a:rPr>
-              <a:t>verificar_perturbaciones()</a:t>
+              <a:t>verificar_perturbaciones()  ·  obtener_lugares_guardados()</a:t>
             </a:r>
             <a:endParaRPr lang="en-US" sz="1300" dirty="0"/>
           </a:p>
@@ -5927,7 +6081,7 @@
               <a:buNone/>
             </a:pPr>
             <a:r>
-              <a:rPr lang="en-US" sz="1100" dirty="0">
+              <a:rPr lang="en-US" sz="900" dirty="0">
                 <a:solidFill>
                   <a:srgbClr val="475569"/>
                 </a:solidFill>
@@ -5935,7 +6089,8 @@
                 <a:ea typeface="Calibri" pitchFamily="34" charset="-122"/>
                 <a:cs typeface="Calibri" pitchFamily="34" charset="-120"/>
               </a:rPr>
-              <a:t>Zona → eventos activos (cierres, marchas)</a:t>
+              <a:t>Zona → eventos activos (cierres, marchas)
+Lugares del usuario inyectados al agente</a:t>
             </a:r>
             <a:endParaRPr lang="en-US" sz="1100" dirty="0"/>
           </a:p>
@@ -5997,6 +6152,10 @@
             <a:prstDash val="solid"/>
           </a:ln>
         </p:spPr>
+        <p:txBody>
+          <a:bodyPr/>
+          <a:p/>
+        </p:txBody>
       </p:sp>
       <p:sp>
         <p:nvSpPr>
@@ -6100,6 +6259,10 @@
             <a:prstDash val="solid"/>
           </a:ln>
         </p:spPr>
+        <p:txBody>
+          <a:bodyPr/>
+          <a:p/>
+        </p:txBody>
       </p:sp>
       <p:sp>
         <p:nvSpPr>
@@ -6164,6 +6327,10 @@
             <a:prstDash val="solid"/>
           </a:ln>
         </p:spPr>
+        <p:txBody>
+          <a:bodyPr/>
+          <a:p/>
+        </p:txBody>
       </p:sp>
       <p:sp>
         <p:nvSpPr>
@@ -6304,6 +6471,10 @@
             <a:prstDash val="solid"/>
           </a:ln>
         </p:spPr>
+        <p:txBody>
+          <a:bodyPr/>
+          <a:p/>
+        </p:txBody>
       </p:sp>
       <p:sp>
         <p:nvSpPr>
@@ -6515,6 +6686,10 @@
             </a:outerShdw>
           </a:effectLst>
         </p:spPr>
+        <p:txBody>
+          <a:bodyPr/>
+          <a:p/>
+        </p:txBody>
       </p:sp>
       <p:sp>
         <p:nvSpPr>
@@ -6540,6 +6715,10 @@
             <a:prstDash val="solid"/>
           </a:ln>
         </p:spPr>
+        <p:txBody>
+          <a:bodyPr/>
+          <a:p/>
+        </p:txBody>
       </p:sp>
       <p:sp>
         <p:nvSpPr>
@@ -6707,6 +6886,10 @@
             </a:outerShdw>
           </a:effectLst>
         </p:spPr>
+        <p:txBody>
+          <a:bodyPr/>
+          <a:p/>
+        </p:txBody>
       </p:sp>
       <p:sp>
         <p:nvSpPr>
@@ -6732,6 +6915,10 @@
             <a:prstDash val="solid"/>
           </a:ln>
         </p:spPr>
+        <p:txBody>
+          <a:bodyPr/>
+          <a:p/>
+        </p:txBody>
       </p:sp>
       <p:sp>
         <p:nvSpPr>
@@ -6899,6 +7086,10 @@
             </a:outerShdw>
           </a:effectLst>
         </p:spPr>
+        <p:txBody>
+          <a:bodyPr/>
+          <a:p/>
+        </p:txBody>
       </p:sp>
       <p:sp>
         <p:nvSpPr>
@@ -6924,6 +7115,10 @@
             <a:prstDash val="solid"/>
           </a:ln>
         </p:spPr>
+        <p:txBody>
+          <a:bodyPr/>
+          <a:p/>
+        </p:txBody>
       </p:sp>
       <p:sp>
         <p:nvSpPr>
@@ -7116,6 +7311,10 @@
             <a:prstDash val="solid"/>
           </a:ln>
         </p:spPr>
+        <p:txBody>
+          <a:bodyPr/>
+          <a:p/>
+        </p:txBody>
       </p:sp>
       <p:sp>
         <p:nvSpPr>
@@ -7219,6 +7418,10 @@
             <a:prstDash val="solid"/>
           </a:ln>
         </p:spPr>
+        <p:txBody>
+          <a:bodyPr/>
+          <a:p/>
+        </p:txBody>
       </p:sp>
       <p:sp>
         <p:nvSpPr>
@@ -7290,6 +7493,10 @@
             </a:outerShdw>
           </a:effectLst>
         </p:spPr>
+        <p:txBody>
+          <a:bodyPr/>
+          <a:p/>
+        </p:txBody>
       </p:sp>
       <p:pic>
         <p:nvPicPr>
@@ -7463,6 +7670,10 @@
             </a:outerShdw>
           </a:effectLst>
         </p:spPr>
+        <p:txBody>
+          <a:bodyPr/>
+          <a:p/>
+        </p:txBody>
       </p:sp>
       <p:pic>
         <p:nvPicPr>
@@ -7636,6 +7847,10 @@
             </a:outerShdw>
           </a:effectLst>
         </p:spPr>
+        <p:txBody>
+          <a:bodyPr/>
+          <a:p/>
+        </p:txBody>
       </p:sp>
       <p:pic>
         <p:nvPicPr>
@@ -7809,6 +8024,10 @@
             </a:outerShdw>
           </a:effectLst>
         </p:spPr>
+        <p:txBody>
+          <a:bodyPr/>
+          <a:p/>
+        </p:txBody>
       </p:sp>
       <p:pic>
         <p:nvPicPr>
@@ -8007,6 +8226,10 @@
             <a:prstDash val="solid"/>
           </a:ln>
         </p:spPr>
+        <p:txBody>
+          <a:bodyPr/>
+          <a:p/>
+        </p:txBody>
       </p:sp>
       <p:sp>
         <p:nvSpPr>
@@ -8110,6 +8333,10 @@
             <a:prstDash val="solid"/>
           </a:ln>
         </p:spPr>
+        <p:txBody>
+          <a:bodyPr/>
+          <a:p/>
+        </p:txBody>
       </p:sp>
       <p:sp>
         <p:nvSpPr>
@@ -8174,6 +8401,10 @@
             <a:prstDash val="solid"/>
           </a:ln>
         </p:spPr>
+        <p:txBody>
+          <a:bodyPr/>
+          <a:p/>
+        </p:txBody>
       </p:sp>
       <p:sp>
         <p:nvSpPr>
@@ -8301,6 +8532,10 @@
             </a:outerShdw>
           </a:effectLst>
         </p:spPr>
+        <p:txBody>
+          <a:bodyPr/>
+          <a:p/>
+        </p:txBody>
       </p:sp>
       <p:sp>
         <p:nvSpPr>
@@ -8411,6 +8646,10 @@
             </a:outerShdw>
           </a:effectLst>
         </p:spPr>
+        <p:txBody>
+          <a:bodyPr/>
+          <a:p/>
+        </p:txBody>
       </p:sp>
       <p:sp>
         <p:nvSpPr>
@@ -8521,6 +8760,10 @@
             </a:outerShdw>
           </a:effectLst>
         </p:spPr>
+        <p:txBody>
+          <a:bodyPr/>
+          <a:p/>
+        </p:txBody>
       </p:sp>
       <p:sp>
         <p:nvSpPr>
@@ -8631,6 +8874,10 @@
             </a:outerShdw>
           </a:effectLst>
         </p:spPr>
+        <p:txBody>
+          <a:bodyPr/>
+          <a:p/>
+        </p:txBody>
       </p:sp>
       <p:sp>
         <p:nvSpPr>
@@ -8741,6 +8988,10 @@
             </a:outerShdw>
           </a:effectLst>
         </p:spPr>
+        <p:txBody>
+          <a:bodyPr/>
+          <a:p/>
+        </p:txBody>
       </p:sp>
       <p:sp>
         <p:nvSpPr>
@@ -8851,6 +9102,10 @@
             </a:outerShdw>
           </a:effectLst>
         </p:spPr>
+        <p:txBody>
+          <a:bodyPr/>
+          <a:p/>
+        </p:txBody>
       </p:sp>
       <p:sp>
         <p:nvSpPr>
@@ -8961,6 +9216,10 @@
             </a:outerShdw>
           </a:effectLst>
         </p:spPr>
+        <p:txBody>
+          <a:bodyPr/>
+          <a:p/>
+        </p:txBody>
       </p:sp>
       <p:sp>
         <p:nvSpPr>
@@ -9071,6 +9330,10 @@
             </a:outerShdw>
           </a:effectLst>
         </p:spPr>
+        <p:txBody>
+          <a:bodyPr/>
+          <a:p/>
+        </p:txBody>
       </p:sp>
       <p:sp>
         <p:nvSpPr>
@@ -9245,6 +9508,10 @@
             <a:prstDash val="solid"/>
           </a:ln>
         </p:spPr>
+        <p:txBody>
+          <a:bodyPr/>
+          <a:p/>
+        </p:txBody>
       </p:sp>
       <p:sp>
         <p:nvSpPr>
@@ -9346,6 +9613,10 @@
             <a:prstDash val="solid"/>
           </a:ln>
         </p:spPr>
+        <p:txBody>
+          <a:bodyPr/>
+          <a:p/>
+        </p:txBody>
       </p:sp>
       <p:sp>
         <p:nvSpPr>
@@ -9458,7 +9729,7 @@
                 <a:ea typeface="Consolas" pitchFamily="34" charset="-122"/>
                 <a:cs typeface="Consolas" pitchFamily="34" charset="-120"/>
               </a:rPr>
-              <a:t>github.com/Palermo01/UrbanFlow_CDMX</a:t>
+              <a:t>github.com/caledelta/UrbanFlow_CDMX</a:t>
             </a:r>
             <a:endParaRPr lang="en-US" sz="1300" dirty="0"/>
           </a:p>
@@ -9520,6 +9791,10 @@
             <a:prstDash val="solid"/>
           </a:ln>
         </p:spPr>
+        <p:txBody>
+          <a:bodyPr/>
+          <a:p/>
+        </p:txBody>
       </p:sp>
       <p:sp>
         <p:nvSpPr>
@@ -9623,6 +9898,10 @@
             <a:prstDash val="solid"/>
           </a:ln>
         </p:spPr>
+        <p:txBody>
+          <a:bodyPr/>
+          <a:p/>
+        </p:txBody>
       </p:sp>
       <p:sp>
         <p:nvSpPr>
@@ -9884,6 +10163,10 @@
             </a:outerShdw>
           </a:effectLst>
         </p:spPr>
+        <p:txBody>
+          <a:bodyPr/>
+          <a:p/>
+        </p:txBody>
       </p:sp>
       <p:sp>
         <p:nvSpPr>
@@ -9909,6 +10192,10 @@
             <a:prstDash val="solid"/>
           </a:ln>
         </p:spPr>
+        <p:txBody>
+          <a:bodyPr/>
+          <a:p/>
+        </p:txBody>
       </p:sp>
       <p:sp>
         <p:nvSpPr>
@@ -10019,6 +10306,10 @@
             </a:outerShdw>
           </a:effectLst>
         </p:spPr>
+        <p:txBody>
+          <a:bodyPr/>
+          <a:p/>
+        </p:txBody>
       </p:sp>
       <p:sp>
         <p:nvSpPr>
@@ -10044,6 +10335,10 @@
             <a:prstDash val="solid"/>
           </a:ln>
         </p:spPr>
+        <p:txBody>
+          <a:bodyPr/>
+          <a:p/>
+        </p:txBody>
       </p:sp>
       <p:sp>
         <p:nvSpPr>
@@ -10154,6 +10449,10 @@
             </a:outerShdw>
           </a:effectLst>
         </p:spPr>
+        <p:txBody>
+          <a:bodyPr/>
+          <a:p/>
+        </p:txBody>
       </p:sp>
       <p:sp>
         <p:nvSpPr>
@@ -10179,6 +10478,10 @@
             <a:prstDash val="solid"/>
           </a:ln>
         </p:spPr>
+        <p:txBody>
+          <a:bodyPr/>
+          <a:p/>
+        </p:txBody>
       </p:sp>
       <p:sp>
         <p:nvSpPr>
@@ -10289,6 +10592,10 @@
             </a:outerShdw>
           </a:effectLst>
         </p:spPr>
+        <p:txBody>
+          <a:bodyPr/>
+          <a:p/>
+        </p:txBody>
       </p:sp>
       <p:sp>
         <p:nvSpPr>
@@ -10314,6 +10621,10 @@
             <a:prstDash val="solid"/>
           </a:ln>
         </p:spPr>
+        <p:txBody>
+          <a:bodyPr/>
+          <a:p/>
+        </p:txBody>
       </p:sp>
       <p:sp>
         <p:nvSpPr>
@@ -10488,6 +10799,10 @@
             <a:prstDash val="solid"/>
           </a:ln>
         </p:spPr>
+        <p:txBody>
+          <a:bodyPr/>
+          <a:p/>
+        </p:txBody>
       </p:sp>
       <p:sp>
         <p:nvSpPr>
@@ -10591,6 +10906,10 @@
             <a:prstDash val="solid"/>
           </a:ln>
         </p:spPr>
+        <p:txBody>
+          <a:bodyPr/>
+          <a:p/>
+        </p:txBody>
       </p:sp>
       <p:sp>
         <p:nvSpPr>
@@ -10806,6 +11125,10 @@
             <a:prstDash val="solid"/>
           </a:ln>
         </p:spPr>
+        <p:txBody>
+          <a:bodyPr/>
+          <a:p/>
+        </p:txBody>
       </p:sp>
       <p:sp>
         <p:nvSpPr>
@@ -11060,6 +11383,10 @@
             <a:prstDash val="solid"/>
           </a:ln>
         </p:spPr>
+        <p:txBody>
+          <a:bodyPr/>
+          <a:p/>
+        </p:txBody>
       </p:sp>
       <p:sp>
         <p:nvSpPr>
@@ -11163,6 +11490,10 @@
             <a:prstDash val="solid"/>
           </a:ln>
         </p:spPr>
+        <p:txBody>
+          <a:bodyPr/>
+          <a:p/>
+        </p:txBody>
       </p:sp>
       <p:sp>
         <p:nvSpPr>
@@ -11266,6 +11597,10 @@
             <a:prstDash val="solid"/>
           </a:ln>
         </p:spPr>
+        <p:txBody>
+          <a:bodyPr/>
+          <a:p/>
+        </p:txBody>
       </p:sp>
       <p:sp>
         <p:nvSpPr>
@@ -11408,6 +11743,10 @@
             <a:prstDash val="solid"/>
           </a:ln>
         </p:spPr>
+        <p:txBody>
+          <a:bodyPr/>
+          <a:p/>
+        </p:txBody>
       </p:sp>
       <p:sp>
         <p:nvSpPr>
@@ -11550,6 +11889,10 @@
             <a:prstDash val="solid"/>
           </a:ln>
         </p:spPr>
+        <p:txBody>
+          <a:bodyPr/>
+          <a:p/>
+        </p:txBody>
       </p:sp>
       <p:sp>
         <p:nvSpPr>
@@ -11685,6 +12028,10 @@
             <a:prstDash val="solid"/>
           </a:ln>
         </p:spPr>
+        <p:txBody>
+          <a:bodyPr/>
+          <a:p/>
+        </p:txBody>
       </p:sp>
       <p:sp>
         <p:nvSpPr>
@@ -11788,6 +12135,10 @@
             <a:prstDash val="solid"/>
           </a:ln>
         </p:spPr>
+        <p:txBody>
+          <a:bodyPr/>
+          <a:p/>
+        </p:txBody>
       </p:sp>
       <p:sp>
         <p:nvSpPr>
@@ -11859,6 +12210,10 @@
             </a:outerShdw>
           </a:effectLst>
         </p:spPr>
+        <p:txBody>
+          <a:bodyPr/>
+          <a:p/>
+        </p:txBody>
       </p:sp>
       <p:sp>
         <p:nvSpPr>
@@ -11884,6 +12239,10 @@
             <a:prstDash val="solid"/>
           </a:ln>
         </p:spPr>
+        <p:txBody>
+          <a:bodyPr/>
+          <a:p/>
+        </p:txBody>
       </p:sp>
       <p:pic>
         <p:nvPicPr>
@@ -12057,6 +12416,10 @@
             </a:outerShdw>
           </a:effectLst>
         </p:spPr>
+        <p:txBody>
+          <a:bodyPr/>
+          <a:p/>
+        </p:txBody>
       </p:sp>
       <p:sp>
         <p:nvSpPr>
@@ -12082,6 +12445,10 @@
             <a:prstDash val="solid"/>
           </a:ln>
         </p:spPr>
+        <p:txBody>
+          <a:bodyPr/>
+          <a:p/>
+        </p:txBody>
       </p:sp>
       <p:pic>
         <p:nvPicPr>
@@ -12255,6 +12622,10 @@
             </a:outerShdw>
           </a:effectLst>
         </p:spPr>
+        <p:txBody>
+          <a:bodyPr/>
+          <a:p/>
+        </p:txBody>
       </p:sp>
       <p:sp>
         <p:nvSpPr>
@@ -12280,6 +12651,10 @@
             <a:prstDash val="solid"/>
           </a:ln>
         </p:spPr>
+        <p:txBody>
+          <a:bodyPr/>
+          <a:p/>
+        </p:txBody>
       </p:sp>
       <p:pic>
         <p:nvPicPr>
@@ -12453,6 +12828,10 @@
             </a:outerShdw>
           </a:effectLst>
         </p:spPr>
+        <p:txBody>
+          <a:bodyPr/>
+          <a:p/>
+        </p:txBody>
       </p:sp>
       <p:sp>
         <p:nvSpPr>
@@ -12478,6 +12857,10 @@
             <a:prstDash val="solid"/>
           </a:ln>
         </p:spPr>
+        <p:txBody>
+          <a:bodyPr/>
+          <a:p/>
+        </p:txBody>
       </p:sp>
       <p:pic>
         <p:nvPicPr>
@@ -12651,6 +13034,10 @@
             </a:outerShdw>
           </a:effectLst>
         </p:spPr>
+        <p:txBody>
+          <a:bodyPr/>
+          <a:p/>
+        </p:txBody>
       </p:sp>
       <p:sp>
         <p:nvSpPr>
@@ -12676,6 +13063,10 @@
             <a:prstDash val="solid"/>
           </a:ln>
         </p:spPr>
+        <p:txBody>
+          <a:bodyPr/>
+          <a:p/>
+        </p:txBody>
       </p:sp>
       <p:pic>
         <p:nvPicPr>
@@ -12734,7 +13125,7 @@
                 <a:ea typeface="Calibri" pitchFamily="34" charset="-122"/>
                 <a:cs typeface="Calibri" pitchFamily="34" charset="-120"/>
               </a:rPr>
-              <a:t>443</a:t>
+              <a:t>720</a:t>
             </a:r>
             <a:endParaRPr lang="en-US" sz="4800" dirty="0"/>
           </a:p>
@@ -12849,6 +13240,10 @@
             </a:outerShdw>
           </a:effectLst>
         </p:spPr>
+        <p:txBody>
+          <a:bodyPr/>
+          <a:p/>
+        </p:txBody>
       </p:sp>
       <p:sp>
         <p:nvSpPr>
@@ -12874,6 +13269,10 @@
             <a:prstDash val="solid"/>
           </a:ln>
         </p:spPr>
+        <p:txBody>
+          <a:bodyPr/>
+          <a:p/>
+        </p:txBody>
       </p:sp>
       <p:pic>
         <p:nvPicPr>
@@ -13072,6 +13471,10 @@
             <a:prstDash val="solid"/>
           </a:ln>
         </p:spPr>
+        <p:txBody>
+          <a:bodyPr/>
+          <a:p/>
+        </p:txBody>
       </p:sp>
       <p:sp>
         <p:nvSpPr>
@@ -13175,6 +13578,10 @@
             <a:prstDash val="solid"/>
           </a:ln>
         </p:spPr>
+        <p:txBody>
+          <a:bodyPr/>
+          <a:p/>
+        </p:txBody>
       </p:sp>
       <p:sp>
         <p:nvSpPr>
@@ -13672,6 +14079,10 @@
             <a:prstDash val="solid"/>
           </a:ln>
         </p:spPr>
+        <p:txBody>
+          <a:bodyPr/>
+          <a:p/>
+        </p:txBody>
       </p:sp>
       <p:sp>
         <p:nvSpPr>
@@ -13736,6 +14147,10 @@
             <a:prstDash val="solid"/>
           </a:ln>
         </p:spPr>
+        <p:txBody>
+          <a:bodyPr/>
+          <a:p/>
+        </p:txBody>
       </p:sp>
       <p:sp>
         <p:nvSpPr>
@@ -13800,6 +14215,10 @@
             <a:prstDash val="solid"/>
           </a:ln>
         </p:spPr>
+        <p:txBody>
+          <a:bodyPr/>
+          <a:p/>
+        </p:txBody>
       </p:sp>
       <p:sp>
         <p:nvSpPr>
@@ -13903,6 +14322,10 @@
             <a:prstDash val="solid"/>
           </a:ln>
         </p:spPr>
+        <p:txBody>
+          <a:bodyPr/>
+          <a:p/>
+        </p:txBody>
       </p:sp>
       <p:sp>
         <p:nvSpPr>
@@ -13967,6 +14390,10 @@
             <a:prstDash val="solid"/>
           </a:ln>
         </p:spPr>
+        <p:txBody>
+          <a:bodyPr/>
+          <a:p/>
+        </p:txBody>
       </p:sp>
       <p:sp>
         <p:nvSpPr>
@@ -14031,6 +14458,10 @@
             <a:prstDash val="solid"/>
           </a:ln>
         </p:spPr>
+        <p:txBody>
+          <a:bodyPr/>
+          <a:p/>
+        </p:txBody>
       </p:sp>
       <p:sp>
         <p:nvSpPr>
@@ -14134,6 +14565,10 @@
             <a:prstDash val="solid"/>
           </a:ln>
         </p:spPr>
+        <p:txBody>
+          <a:bodyPr/>
+          <a:p/>
+        </p:txBody>
       </p:sp>
       <p:sp>
         <p:nvSpPr>
@@ -14198,6 +14633,10 @@
             <a:prstDash val="solid"/>
           </a:ln>
         </p:spPr>
+        <p:txBody>
+          <a:bodyPr/>
+          <a:p/>
+        </p:txBody>
       </p:sp>
       <p:sp>
         <p:nvSpPr>
@@ -14262,6 +14701,10 @@
             <a:prstDash val="solid"/>
           </a:ln>
         </p:spPr>
+        <p:txBody>
+          <a:bodyPr/>
+          <a:p/>
+        </p:txBody>
       </p:sp>
       <p:sp>
         <p:nvSpPr>
@@ -14436,6 +14879,10 @@
             <a:prstDash val="solid"/>
           </a:ln>
         </p:spPr>
+        <p:txBody>
+          <a:bodyPr/>
+          <a:p/>
+        </p:txBody>
       </p:sp>
       <p:sp>
         <p:nvSpPr>
@@ -14539,6 +14986,10 @@
             <a:prstDash val="solid"/>
           </a:ln>
         </p:spPr>
+        <p:txBody>
+          <a:bodyPr/>
+          <a:p/>
+        </p:txBody>
       </p:sp>
       <p:sp>
         <p:nvSpPr>
@@ -14837,6 +15288,10 @@
             <a:prstDash val="solid"/>
           </a:ln>
         </p:spPr>
+        <p:txBody>
+          <a:bodyPr/>
+          <a:p/>
+        </p:txBody>
       </p:sp>
       <p:sp>
         <p:nvSpPr>
@@ -14862,6 +15317,10 @@
             <a:prstDash val="solid"/>
           </a:ln>
         </p:spPr>
+        <p:txBody>
+          <a:bodyPr/>
+          <a:p/>
+        </p:txBody>
       </p:sp>
       <p:sp>
         <p:nvSpPr>
@@ -14887,6 +15346,10 @@
             <a:prstDash val="solid"/>
           </a:ln>
         </p:spPr>
+        <p:txBody>
+          <a:bodyPr/>
+          <a:p/>
+        </p:txBody>
       </p:sp>
       <p:sp>
         <p:nvSpPr>
@@ -14912,6 +15375,10 @@
             <a:prstDash val="solid"/>
           </a:ln>
         </p:spPr>
+        <p:txBody>
+          <a:bodyPr/>
+          <a:p/>
+        </p:txBody>
       </p:sp>
       <p:sp>
         <p:nvSpPr>
@@ -14937,6 +15404,10 @@
             <a:prstDash val="solid"/>
           </a:ln>
         </p:spPr>
+        <p:txBody>
+          <a:bodyPr/>
+          <a:p/>
+        </p:txBody>
       </p:sp>
       <p:sp>
         <p:nvSpPr>
@@ -14962,6 +15433,10 @@
             <a:prstDash val="solid"/>
           </a:ln>
         </p:spPr>
+        <p:txBody>
+          <a:bodyPr/>
+          <a:p/>
+        </p:txBody>
       </p:sp>
       <p:sp>
         <p:nvSpPr>
@@ -14987,6 +15462,10 @@
             <a:prstDash val="solid"/>
           </a:ln>
         </p:spPr>
+        <p:txBody>
+          <a:bodyPr/>
+          <a:p/>
+        </p:txBody>
       </p:sp>
       <p:sp>
         <p:nvSpPr>
@@ -15012,6 +15491,10 @@
             <a:prstDash val="solid"/>
           </a:ln>
         </p:spPr>
+        <p:txBody>
+          <a:bodyPr/>
+          <a:p/>
+        </p:txBody>
       </p:sp>
       <p:sp>
         <p:nvSpPr>
@@ -15037,6 +15520,10 @@
             <a:prstDash val="solid"/>
           </a:ln>
         </p:spPr>
+        <p:txBody>
+          <a:bodyPr/>
+          <a:p/>
+        </p:txBody>
       </p:sp>
       <p:sp>
         <p:nvSpPr>
@@ -15062,6 +15549,10 @@
             <a:prstDash val="solid"/>
           </a:ln>
         </p:spPr>
+        <p:txBody>
+          <a:bodyPr/>
+          <a:p/>
+        </p:txBody>
       </p:sp>
       <p:sp>
         <p:nvSpPr>
@@ -15087,6 +15578,10 @@
             <a:prstDash val="solid"/>
           </a:ln>
         </p:spPr>
+        <p:txBody>
+          <a:bodyPr/>
+          <a:p/>
+        </p:txBody>
       </p:sp>
       <p:sp>
         <p:nvSpPr>
@@ -15112,6 +15607,10 @@
             <a:prstDash val="solid"/>
           </a:ln>
         </p:spPr>
+        <p:txBody>
+          <a:bodyPr/>
+          <a:p/>
+        </p:txBody>
       </p:sp>
       <p:sp>
         <p:nvSpPr>
@@ -15137,6 +15636,10 @@
             <a:prstDash val="solid"/>
           </a:ln>
         </p:spPr>
+        <p:txBody>
+          <a:bodyPr/>
+          <a:p/>
+        </p:txBody>
       </p:sp>
       <p:sp>
         <p:nvSpPr>
@@ -15162,6 +15665,10 @@
             <a:prstDash val="solid"/>
           </a:ln>
         </p:spPr>
+        <p:txBody>
+          <a:bodyPr/>
+          <a:p/>
+        </p:txBody>
       </p:sp>
       <p:sp>
         <p:nvSpPr>
@@ -15187,6 +15694,10 @@
             <a:prstDash val="solid"/>
           </a:ln>
         </p:spPr>
+        <p:txBody>
+          <a:bodyPr/>
+          <a:p/>
+        </p:txBody>
       </p:sp>
       <p:sp>
         <p:nvSpPr>
@@ -15212,6 +15723,10 @@
             <a:prstDash val="solid"/>
           </a:ln>
         </p:spPr>
+        <p:txBody>
+          <a:bodyPr/>
+          <a:p/>
+        </p:txBody>
       </p:sp>
       <p:sp>
         <p:nvSpPr>
@@ -15237,6 +15752,10 @@
             <a:prstDash val="solid"/>
           </a:ln>
         </p:spPr>
+        <p:txBody>
+          <a:bodyPr/>
+          <a:p/>
+        </p:txBody>
       </p:sp>
       <p:sp>
         <p:nvSpPr>
@@ -15262,6 +15781,10 @@
             <a:prstDash val="solid"/>
           </a:ln>
         </p:spPr>
+        <p:txBody>
+          <a:bodyPr/>
+          <a:p/>
+        </p:txBody>
       </p:sp>
       <p:sp>
         <p:nvSpPr>
@@ -15287,6 +15810,10 @@
             <a:prstDash val="solid"/>
           </a:ln>
         </p:spPr>
+        <p:txBody>
+          <a:bodyPr/>
+          <a:p/>
+        </p:txBody>
       </p:sp>
       <p:sp>
         <p:nvSpPr>
@@ -15539,6 +16066,10 @@
             <a:prstDash val="solid"/>
           </a:ln>
         </p:spPr>
+        <p:txBody>
+          <a:bodyPr/>
+          <a:p/>
+        </p:txBody>
       </p:sp>
       <p:sp>
         <p:nvSpPr>
@@ -15642,6 +16173,10 @@
             <a:prstDash val="solid"/>
           </a:ln>
         </p:spPr>
+        <p:txBody>
+          <a:bodyPr/>
+          <a:p/>
+        </p:txBody>
       </p:sp>
       <p:sp>
         <p:nvSpPr>
@@ -15752,6 +16287,10 @@
             </a:outerShdw>
           </a:effectLst>
         </p:spPr>
+        <p:txBody>
+          <a:bodyPr/>
+          <a:p/>
+        </p:txBody>
       </p:sp>
       <p:sp>
         <p:nvSpPr>
@@ -15777,6 +16316,10 @@
             <a:prstDash val="solid"/>
           </a:ln>
         </p:spPr>
+        <p:txBody>
+          <a:bodyPr/>
+          <a:p/>
+        </p:txBody>
       </p:sp>
       <p:pic>
         <p:nvPicPr>
@@ -15950,6 +16493,10 @@
             </a:outerShdw>
           </a:effectLst>
         </p:spPr>
+        <p:txBody>
+          <a:bodyPr/>
+          <a:p/>
+        </p:txBody>
       </p:sp>
       <p:sp>
         <p:nvSpPr>
@@ -15975,6 +16522,10 @@
             <a:prstDash val="solid"/>
           </a:ln>
         </p:spPr>
+        <p:txBody>
+          <a:bodyPr/>
+          <a:p/>
+        </p:txBody>
       </p:sp>
       <p:pic>
         <p:nvPicPr>
@@ -16148,6 +16699,10 @@
             </a:outerShdw>
           </a:effectLst>
         </p:spPr>
+        <p:txBody>
+          <a:bodyPr/>
+          <a:p/>
+        </p:txBody>
       </p:sp>
       <p:sp>
         <p:nvSpPr>
@@ -16173,6 +16728,10 @@
             <a:prstDash val="solid"/>
           </a:ln>
         </p:spPr>
+        <p:txBody>
+          <a:bodyPr/>
+          <a:p/>
+        </p:txBody>
       </p:sp>
       <p:pic>
         <p:nvPicPr>
@@ -16346,6 +16905,10 @@
             </a:outerShdw>
           </a:effectLst>
         </p:spPr>
+        <p:txBody>
+          <a:bodyPr/>
+          <a:p/>
+        </p:txBody>
       </p:sp>
       <p:sp>
         <p:nvSpPr>
@@ -16371,6 +16934,10 @@
             <a:prstDash val="solid"/>
           </a:ln>
         </p:spPr>
+        <p:txBody>
+          <a:bodyPr/>
+          <a:p/>
+        </p:txBody>
       </p:sp>
       <p:pic>
         <p:nvPicPr>
@@ -16569,6 +17136,10 @@
             <a:prstDash val="solid"/>
           </a:ln>
         </p:spPr>
+        <p:txBody>
+          <a:bodyPr/>
+          <a:p/>
+        </p:txBody>
       </p:sp>
       <p:sp>
         <p:nvSpPr>
@@ -16672,6 +17243,10 @@
             <a:prstDash val="solid"/>
           </a:ln>
         </p:spPr>
+        <p:txBody>
+          <a:bodyPr/>
+          <a:p/>
+        </p:txBody>
       </p:sp>
       <p:sp>
         <p:nvSpPr>
@@ -16736,6 +17311,10 @@
             <a:prstDash val="solid"/>
           </a:ln>
         </p:spPr>
+        <p:txBody>
+          <a:bodyPr/>
+          <a:p/>
+        </p:txBody>
       </p:sp>
       <p:sp>
         <p:nvSpPr>
@@ -16846,6 +17425,10 @@
             </a:outerShdw>
           </a:effectLst>
         </p:spPr>
+        <p:txBody>
+          <a:bodyPr/>
+          <a:p/>
+        </p:txBody>
       </p:sp>
       <p:sp>
         <p:nvSpPr>
@@ -16871,6 +17454,10 @@
             <a:prstDash val="solid"/>
           </a:ln>
         </p:spPr>
+        <p:txBody>
+          <a:bodyPr/>
+          <a:p/>
+        </p:txBody>
       </p:sp>
       <p:sp>
         <p:nvSpPr>
@@ -17020,6 +17607,10 @@
             </a:outerShdw>
           </a:effectLst>
         </p:spPr>
+        <p:txBody>
+          <a:bodyPr/>
+          <a:p/>
+        </p:txBody>
       </p:sp>
       <p:sp>
         <p:nvSpPr>
@@ -17045,6 +17636,10 @@
             <a:prstDash val="solid"/>
           </a:ln>
         </p:spPr>
+        <p:txBody>
+          <a:bodyPr/>
+          <a:p/>
+        </p:txBody>
       </p:sp>
       <p:sp>
         <p:nvSpPr>
@@ -17194,6 +17789,10 @@
             </a:outerShdw>
           </a:effectLst>
         </p:spPr>
+        <p:txBody>
+          <a:bodyPr/>
+          <a:p/>
+        </p:txBody>
       </p:sp>
       <p:sp>
         <p:nvSpPr>
@@ -17219,6 +17818,10 @@
             <a:prstDash val="solid"/>
           </a:ln>
         </p:spPr>
+        <p:txBody>
+          <a:bodyPr/>
+          <a:p/>
+        </p:txBody>
       </p:sp>
       <p:sp>
         <p:nvSpPr>

</xml_diff>